<commit_message>
Docs: passport flat-fee clarity + ERP-inclusive bundles; remove implausible 92% AI-adoption stat from all strategy artifacts
- GTM V2.0: Trust priced as flat annual fee per tier (orgs relied on selects tier, not per-check/per-org); new Build-inclusive bundles (Operate & Prove, Full Platform, Donor Impact Suite)
- One-pager: bundles table now includes the two Build bundles
- Strategy V4.0 / Grant MA / Product MA / Deck V12: drop '92% of nonprofits use AI / 7% impact'; lead with defensible funder-side gap (97% of foundations don't screen with AI; 1 in 10 accept AI-generated proposals)

Co-Authored-By: Claude Opus 4.8 <noreply@anthropic.com>
</commit_message>
<xml_diff>
--- a/docs/Kuja_Pitch_Deck_V12_Professional_July2026.pptx
+++ b/docs/Kuja_Pitch_Deck_V12_Professional_July2026.pptx
@@ -4189,7 +4189,7 @@
                 <a:ea typeface="Georgia" pitchFamily="34" charset="-122"/>
                 <a:cs typeface="Georgia" pitchFamily="34" charset="-120"/>
               </a:rPr>
-              <a:t>Adoption is universal. Impact is not. The window is open.</a:t>
+              <a:t>Foundations barely use AI. The window is open.</a:t>
             </a:r>
             <a:endParaRPr lang="en-US" sz="3800" dirty="0"/>
           </a:p>
@@ -4228,7 +4228,7 @@
                 <a:ea typeface="Georgia" pitchFamily="34" charset="-122"/>
                 <a:cs typeface="Georgia" pitchFamily="34" charset="-120"/>
               </a:rPr>
-              <a:t>92%</a:t>
+              <a:t>97%</a:t>
             </a:r>
             <a:endParaRPr lang="en-US" sz="11000" dirty="0"/>
           </a:p>
@@ -4292,7 +4292,7 @@
                 <a:ea typeface="Calibri" pitchFamily="34" charset="-122"/>
                 <a:cs typeface="Calibri" pitchFamily="34" charset="-120"/>
               </a:rPr>
-              <a:t>of nonprofits use AI tools</a:t>
+              <a:t>of foundations NOT using AI to screen applications</a:t>
             </a:r>
             <a:endParaRPr lang="en-US" sz="1300" dirty="0"/>
           </a:p>
@@ -4331,7 +4331,7 @@
                 <a:ea typeface="Georgia" pitchFamily="34" charset="-122"/>
                 <a:cs typeface="Georgia" pitchFamily="34" charset="-120"/>
               </a:rPr>
-              <a:t>7%</a:t>
+              <a:t>10%</a:t>
             </a:r>
             <a:endParaRPr lang="en-US" sz="11000" dirty="0"/>
           </a:p>
@@ -4395,7 +4395,7 @@
                 <a:ea typeface="Calibri" pitchFamily="34" charset="-122"/>
                 <a:cs typeface="Calibri" pitchFamily="34" charset="-120"/>
               </a:rPr>
-              <a:t>report major organizational impact</a:t>
+              <a:t>of funders would accept AI-generated proposal content</a:t>
             </a:r>
             <a:endParaRPr lang="en-US" sz="1300" dirty="0"/>
           </a:p>
@@ -4434,7 +4434,7 @@
                 <a:ea typeface="Georgia" pitchFamily="34" charset="-122"/>
                 <a:cs typeface="Georgia" pitchFamily="34" charset="-120"/>
               </a:rPr>
-              <a:t>97%</a:t>
+              <a:t>98%</a:t>
             </a:r>
             <a:endParaRPr lang="en-US" sz="11000" dirty="0"/>
           </a:p>
@@ -4498,7 +4498,7 @@
                 <a:ea typeface="Calibri" pitchFamily="34" charset="-122"/>
                 <a:cs typeface="Calibri" pitchFamily="34" charset="-120"/>
               </a:rPr>
-              <a:t>of foundations NOT yet using AI to screen applications</a:t>
+              <a:t>of African languages unsupported by mainstream LLMs</a:t>
             </a:r>
             <a:endParaRPr lang="en-US" sz="1300" dirty="0"/>
           </a:p>

</xml_diff>